<commit_message>
Some issues with indentations were addressed.
</commit_message>
<xml_diff>
--- a/demo.pptx
+++ b/demo.pptx
@@ -5148,7 +5148,7 @@
           </a:bodyPr>
           <a:lstStyle/>
           <a:p>
-            <a:pPr lvl="0" indent="0" marL="0">
+            <a:pPr lvl="0" indent="-338328" marL="338328">
               <a:buNone/>
             </a:pPr>
             <a:r>
@@ -5180,7 +5180,7 @@
           </a:bodyPr>
           <a:lstStyle/>
           <a:p>
-            <a:pPr lvl="0" indent="0" marL="0">
+            <a:pPr lvl="0" indent="-338328" marL="338328">
               <a:buNone/>
             </a:pPr>
             <a:r>
@@ -5239,7 +5239,7 @@
           </a:bodyPr>
           <a:lstStyle/>
           <a:p>
-            <a:pPr lvl="0" indent="0" marL="0">
+            <a:pPr lvl="0" indent="-338328" marL="338328">
               <a:buNone/>
             </a:pPr>
             <a:r>
@@ -5266,56 +5266,56 @@
           </a:bodyPr>
           <a:lstStyle/>
           <a:p>
-            <a:pPr lvl="0"/>
+            <a:pPr lvl="0" marL="338328" indent="-338328"/>
             <a:r>
               <a:rPr/>
               <a:t>Highlights of this week:</a:t>
             </a:r>
           </a:p>
           <a:p>
-            <a:pPr lvl="1"/>
+            <a:pPr lvl="1" marL="676656" indent="-338328"/>
             <a:r>
               <a:rPr/>
               <a:t>iSCAT-Confocal colocalization for 50% BMP with DOPE-Biotin and DOPE-Cy5 (unsuccessful)</a:t>
             </a:r>
           </a:p>
           <a:p>
-            <a:pPr lvl="1"/>
+            <a:pPr lvl="1" marL="676656" indent="-338328"/>
             <a:r>
               <a:rPr/>
               <a:t>Prepared new batch of SUV for 25% BMP with DOPE-Biotin and DOPE-Cy5 markers</a:t>
             </a:r>
           </a:p>
           <a:p>
-            <a:pPr lvl="1"/>
+            <a:pPr lvl="1" marL="676656" indent="-338328"/>
             <a:r>
               <a:rPr/>
               <a:t>Single molecule emitter validation</a:t>
             </a:r>
           </a:p>
           <a:p>
-            <a:pPr lvl="0"/>
+            <a:pPr lvl="0" marL="338328" indent="-338328"/>
             <a:r>
               <a:rPr/>
               <a:t>Next:</a:t>
             </a:r>
           </a:p>
           <a:p>
-            <a:pPr lvl="1"/>
+            <a:pPr lvl="1" marL="676656" indent="-338328"/>
             <a:r>
               <a:rPr/>
               <a:t>Validate the single molecule emitter for other data sets with multistep fitting.</a:t>
             </a:r>
           </a:p>
           <a:p>
-            <a:pPr lvl="1"/>
+            <a:pPr lvl="1" marL="676656" indent="-338328"/>
             <a:r>
               <a:rPr/>
               <a:t>Do SPT with iSCAT for BMP 25% + TAT</a:t>
             </a:r>
           </a:p>
           <a:p>
-            <a:pPr lvl="1"/>
+            <a:pPr lvl="1" marL="676656" indent="-338328"/>
             <a:r>
               <a:rPr/>
               <a:t>As </a:t>
@@ -5330,21 +5330,21 @@
             </a:r>
           </a:p>
           <a:p>
-            <a:pPr lvl="1"/>
+            <a:pPr lvl="1" marL="676656" indent="-338328"/>
             <a:r>
               <a:rPr/>
               <a:t>Do more experiments for phase separation</a:t>
             </a:r>
           </a:p>
           <a:p>
-            <a:pPr lvl="1"/>
+            <a:pPr lvl="1" marL="676656" indent="-338328"/>
             <a:r>
               <a:rPr/>
               <a:t>Find a way to calibrate confocal image with the iSCAT image</a:t>
             </a:r>
           </a:p>
           <a:p>
-            <a:pPr lvl="1"/>
+            <a:pPr lvl="1" marL="676656" indent="-338328"/>
             <a:r>
               <a:rPr/>
               <a:t>More simulation for the random phase mask to find the optimal parameters for the diffuser</a:t>
@@ -5395,7 +5395,7 @@
           </a:bodyPr>
           <a:lstStyle/>
           <a:p>
-            <a:pPr lvl="0" indent="0" marL="0">
+            <a:pPr lvl="0" indent="-338328" marL="338328">
               <a:buNone/>
             </a:pPr>
             <a:r>
@@ -5422,7 +5422,7 @@
           </a:bodyPr>
           <a:lstStyle/>
           <a:p>
-            <a:pPr lvl="0" indent="0" marL="0">
+            <a:pPr lvl="0" indent="-338328" marL="338328">
               <a:buNone/>
             </a:pPr>
             <a:r>
@@ -5479,7 +5479,7 @@
           </a:bodyPr>
           <a:lstStyle/>
           <a:p>
-            <a:pPr lvl="0" indent="0" marL="0">
+            <a:pPr lvl="0" indent="-338328" marL="338328">
               <a:buNone/>
             </a:pPr>
             <a:r>
@@ -5506,7 +5506,7 @@
           </a:bodyPr>
           <a:lstStyle/>
           <a:p>
-            <a:pPr lvl="0" indent="0" marL="0">
+            <a:pPr lvl="0" indent="-338328" marL="338328">
               <a:buNone/>
             </a:pPr>
             <a:r>
@@ -5837,7 +5837,7 @@
           </a:bodyPr>
           <a:lstStyle/>
           <a:p>
-            <a:pPr lvl="0" indent="0" marL="0">
+            <a:pPr lvl="0" indent="-338328" marL="338328">
               <a:buNone/>
             </a:pPr>
             <a:r>
@@ -5894,7 +5894,7 @@
           </a:bodyPr>
           <a:lstStyle/>
           <a:p>
-            <a:pPr lvl="0" indent="0" marL="0">
+            <a:pPr lvl="0" indent="-338328" marL="338328">
               <a:buNone/>
             </a:pPr>
             <a:r>
@@ -5903,7 +5903,7 @@
             </a:r>
           </a:p>
           <a:p>
-            <a:pPr lvl="0" indent="0" marL="0">
+            <a:pPr lvl="0" indent="-338328" marL="338328">
               <a:buNone/>
             </a:pPr>
             <a:r>
@@ -5996,7 +5996,7 @@
           </a:bodyPr>
           <a:lstStyle/>
           <a:p>
-            <a:pPr lvl="0" indent="0" marL="0">
+            <a:pPr lvl="0" indent="-338328" marL="338328">
               <a:buNone/>
             </a:pPr>
             <a:r>
@@ -6023,7 +6023,7 @@
           </a:bodyPr>
           <a:lstStyle/>
           <a:p>
-            <a:pPr lvl="0" indent="0" marL="0">
+            <a:pPr lvl="0" indent="-338328" marL="338328">
               <a:buNone/>
             </a:pPr>
             <a:r>
@@ -6110,7 +6110,7 @@
           </a:bodyPr>
           <a:lstStyle/>
           <a:p>
-            <a:pPr lvl="0" indent="0" marL="0">
+            <a:pPr lvl="0" indent="-338328" marL="338328">
               <a:buNone/>
             </a:pPr>
             <a:r>
@@ -6137,7 +6137,7 @@
           </a:bodyPr>
           <a:lstStyle/>
           <a:p>
-            <a:pPr lvl="0" indent="0" marL="0">
+            <a:pPr lvl="0" indent="-338328" marL="338328">
               <a:buNone/>
             </a:pPr>
             <a:r>
@@ -6154,7 +6154,7 @@
             </a:r>
           </a:p>
           <a:p>
-            <a:pPr lvl="0" indent="0" marL="0">
+            <a:pPr lvl="0" indent="-338328" marL="338328">
               <a:buNone/>
             </a:pPr>
             <a:r>
@@ -6163,7 +6163,7 @@
             </a:r>
           </a:p>
           <a:p>
-            <a:pPr lvl="0" indent="0" marL="0">
+            <a:pPr lvl="0" indent="-338328" marL="338328">
               <a:buNone/>
             </a:pPr>
             <a:r>
@@ -6180,7 +6180,7 @@
             </a:r>
           </a:p>
           <a:p>
-            <a:pPr lvl="0" indent="0" marL="0">
+            <a:pPr lvl="0" indent="-338328" marL="338328">
               <a:buNone/>
             </a:pPr>
             <a:r>
@@ -6263,7 +6263,7 @@
           </a:bodyPr>
           <a:lstStyle/>
           <a:p>
-            <a:pPr lvl="0" indent="0" marL="0">
+            <a:pPr lvl="0" indent="-338328" marL="338328">
               <a:buNone/>
             </a:pPr>
             <a:r>
@@ -6290,7 +6290,7 @@
           </a:bodyPr>
           <a:lstStyle/>
           <a:p>
-            <a:pPr lvl="0" indent="0" marL="0">
+            <a:pPr lvl="0" indent="-338328" marL="338328">
               <a:spcBef>
                 <a:spcPts val="3000"/>
               </a:spcBef>
@@ -6302,21 +6302,21 @@
             </a:r>
           </a:p>
           <a:p>
-            <a:pPr lvl="0"/>
+            <a:pPr lvl="0" marL="338328" indent="-338328"/>
             <a:r>
               <a:rPr/>
               <a:t>The fitting for TAT affinity is improved for better fitting and better visualization.</a:t>
             </a:r>
           </a:p>
           <a:p>
-            <a:pPr lvl="0"/>
+            <a:pPr lvl="0" marL="338328" indent="-338328"/>
             <a:r>
               <a:rPr/>
               <a:t>Time dependent images for SPT analysis is done for 0, 1, 2, 3, 4 and 5 hours after TAT addition.</a:t>
             </a:r>
           </a:p>
           <a:p>
-            <a:pPr lvl="0" indent="0" marL="0">
+            <a:pPr lvl="0" indent="-338328" marL="338328">
               <a:spcBef>
                 <a:spcPts val="3000"/>
               </a:spcBef>
@@ -6328,14 +6328,14 @@
             </a:r>
           </a:p>
           <a:p>
-            <a:pPr lvl="0"/>
+            <a:pPr lvl="0" marL="338328" indent="-338328"/>
             <a:r>
               <a:rPr/>
               <a:t>…</a:t>
             </a:r>
           </a:p>
           <a:p>
-            <a:pPr lvl="0" indent="0" marL="0">
+            <a:pPr lvl="0" indent="-338328" marL="338328">
               <a:spcBef>
                 <a:spcPts val="3000"/>
               </a:spcBef>
@@ -6347,14 +6347,14 @@
             </a:r>
           </a:p>
           <a:p>
-            <a:pPr lvl="0"/>
+            <a:pPr lvl="0" marL="338328" indent="-338328"/>
             <a:r>
               <a:rPr/>
               <a:t>Based on the concentration dependence of LNPs the next round of experiments will be done with 10x higher concentration.</a:t>
             </a:r>
           </a:p>
           <a:p>
-            <a:pPr lvl="0" indent="0" marL="0">
+            <a:pPr lvl="0" indent="-338328" marL="338328">
               <a:spcBef>
                 <a:spcPts val="3000"/>
               </a:spcBef>
@@ -6366,14 +6366,14 @@
             </a:r>
           </a:p>
           <a:p>
-            <a:pPr lvl="0"/>
+            <a:pPr lvl="0" marL="338328" indent="-338328"/>
             <a:r>
               <a:rPr/>
               <a:t>Temperature dependent experiment shows that domains formed after TAT addition disappear at 50 °C. However, when the sample is cooled down to room temperature, the domains do not reappear.</a:t>
             </a:r>
           </a:p>
           <a:p>
-            <a:pPr lvl="0"/>
+            <a:pPr lvl="0" marL="338328" indent="-338328"/>
             <a:r>
               <a:rPr/>
               <a:t>Next is to analyze the SPT for DOPE-Atto488 and Cholesterol-Bodipy to see if the diffusion coefficient is different for the two markers.</a:t>

</xml_diff>

<commit_message>
Fix the bullet-text gap inconsistency.
</commit_message>
<xml_diff>
--- a/demo.pptx
+++ b/demo.pptx
@@ -5148,7 +5148,7 @@
           </a:bodyPr>
           <a:lstStyle/>
           <a:p>
-            <a:pPr lvl="0" indent="-338328" marL="338328">
+            <a:pPr lvl="0" indent="-182880" marL="338328">
               <a:buNone/>
             </a:pPr>
             <a:r>
@@ -5180,7 +5180,7 @@
           </a:bodyPr>
           <a:lstStyle/>
           <a:p>
-            <a:pPr lvl="0" indent="-338328" marL="338328">
+            <a:pPr lvl="0" indent="-182880" marL="338328">
               <a:buNone/>
             </a:pPr>
             <a:r>
@@ -5239,7 +5239,7 @@
           </a:bodyPr>
           <a:lstStyle/>
           <a:p>
-            <a:pPr lvl="0" indent="-338328" marL="338328">
+            <a:pPr lvl="0" indent="-182880" marL="338328">
               <a:buNone/>
             </a:pPr>
             <a:r>
@@ -5266,56 +5266,56 @@
           </a:bodyPr>
           <a:lstStyle/>
           <a:p>
-            <a:pPr lvl="0" marL="338328" indent="-338328"/>
+            <a:pPr lvl="0" marL="338328" indent="-182880"/>
             <a:r>
               <a:rPr/>
               <a:t>Highlights of this week:</a:t>
             </a:r>
           </a:p>
           <a:p>
-            <a:pPr lvl="1" marL="676656" indent="-338328"/>
+            <a:pPr lvl="1" marL="676656" indent="-182880"/>
             <a:r>
               <a:rPr/>
               <a:t>iSCAT-Confocal colocalization for 50% BMP with DOPE-Biotin and DOPE-Cy5 (unsuccessful)</a:t>
             </a:r>
           </a:p>
           <a:p>
-            <a:pPr lvl="1" marL="676656" indent="-338328"/>
+            <a:pPr lvl="1" marL="676656" indent="-182880"/>
             <a:r>
               <a:rPr/>
               <a:t>Prepared new batch of SUV for 25% BMP with DOPE-Biotin and DOPE-Cy5 markers</a:t>
             </a:r>
           </a:p>
           <a:p>
-            <a:pPr lvl="1" marL="676656" indent="-338328"/>
+            <a:pPr lvl="1" marL="676656" indent="-182880"/>
             <a:r>
               <a:rPr/>
               <a:t>Single molecule emitter validation</a:t>
             </a:r>
           </a:p>
           <a:p>
-            <a:pPr lvl="0" marL="338328" indent="-338328"/>
+            <a:pPr lvl="0" marL="338328" indent="-182880"/>
             <a:r>
               <a:rPr/>
               <a:t>Next:</a:t>
             </a:r>
           </a:p>
           <a:p>
-            <a:pPr lvl="1" marL="676656" indent="-338328"/>
+            <a:pPr lvl="1" marL="676656" indent="-182880"/>
             <a:r>
               <a:rPr/>
               <a:t>Validate the single molecule emitter for other data sets with multistep fitting.</a:t>
             </a:r>
           </a:p>
           <a:p>
-            <a:pPr lvl="1" marL="676656" indent="-338328"/>
+            <a:pPr lvl="1" marL="676656" indent="-182880"/>
             <a:r>
               <a:rPr/>
               <a:t>Do SPT with iSCAT for BMP 25% + TAT</a:t>
             </a:r>
           </a:p>
           <a:p>
-            <a:pPr lvl="1" marL="676656" indent="-338328"/>
+            <a:pPr lvl="1" marL="676656" indent="-182880"/>
             <a:r>
               <a:rPr/>
               <a:t>As </a:t>
@@ -5330,21 +5330,21 @@
             </a:r>
           </a:p>
           <a:p>
-            <a:pPr lvl="1" marL="676656" indent="-338328"/>
+            <a:pPr lvl="1" marL="676656" indent="-182880"/>
             <a:r>
               <a:rPr/>
               <a:t>Do more experiments for phase separation</a:t>
             </a:r>
           </a:p>
           <a:p>
-            <a:pPr lvl="1" marL="676656" indent="-338328"/>
+            <a:pPr lvl="1" marL="676656" indent="-182880"/>
             <a:r>
               <a:rPr/>
               <a:t>Find a way to calibrate confocal image with the iSCAT image</a:t>
             </a:r>
           </a:p>
           <a:p>
-            <a:pPr lvl="1" marL="676656" indent="-338328"/>
+            <a:pPr lvl="1" marL="676656" indent="-182880"/>
             <a:r>
               <a:rPr/>
               <a:t>More simulation for the random phase mask to find the optimal parameters for the diffuser</a:t>
@@ -5395,7 +5395,7 @@
           </a:bodyPr>
           <a:lstStyle/>
           <a:p>
-            <a:pPr lvl="0" indent="-338328" marL="338328">
+            <a:pPr lvl="0" indent="-182880" marL="338328">
               <a:buNone/>
             </a:pPr>
             <a:r>
@@ -5422,7 +5422,7 @@
           </a:bodyPr>
           <a:lstStyle/>
           <a:p>
-            <a:pPr lvl="0" indent="-338328" marL="338328">
+            <a:pPr lvl="0" indent="-182880" marL="338328">
               <a:buNone/>
             </a:pPr>
             <a:r>
@@ -5479,7 +5479,7 @@
           </a:bodyPr>
           <a:lstStyle/>
           <a:p>
-            <a:pPr lvl="0" indent="-338328" marL="338328">
+            <a:pPr lvl="0" indent="-182880" marL="338328">
               <a:buNone/>
             </a:pPr>
             <a:r>
@@ -5506,7 +5506,7 @@
           </a:bodyPr>
           <a:lstStyle/>
           <a:p>
-            <a:pPr lvl="0" indent="-338328" marL="338328">
+            <a:pPr lvl="0" indent="-182880" marL="338328">
               <a:buNone/>
             </a:pPr>
             <a:r>
@@ -5837,7 +5837,7 @@
           </a:bodyPr>
           <a:lstStyle/>
           <a:p>
-            <a:pPr lvl="0" indent="-338328" marL="338328">
+            <a:pPr lvl="0" indent="-182880" marL="338328">
               <a:buNone/>
             </a:pPr>
             <a:r>
@@ -5894,7 +5894,7 @@
           </a:bodyPr>
           <a:lstStyle/>
           <a:p>
-            <a:pPr lvl="0" indent="-338328" marL="338328">
+            <a:pPr lvl="0" indent="-182880" marL="338328">
               <a:buNone/>
             </a:pPr>
             <a:r>
@@ -5903,7 +5903,7 @@
             </a:r>
           </a:p>
           <a:p>
-            <a:pPr lvl="0" indent="-338328" marL="338328">
+            <a:pPr lvl="0" indent="-182880" marL="338328">
               <a:buNone/>
             </a:pPr>
             <a:r>
@@ -5996,7 +5996,7 @@
           </a:bodyPr>
           <a:lstStyle/>
           <a:p>
-            <a:pPr lvl="0" indent="-338328" marL="338328">
+            <a:pPr lvl="0" indent="-182880" marL="338328">
               <a:buNone/>
             </a:pPr>
             <a:r>
@@ -6023,7 +6023,7 @@
           </a:bodyPr>
           <a:lstStyle/>
           <a:p>
-            <a:pPr lvl="0" indent="-338328" marL="338328">
+            <a:pPr lvl="0" indent="-182880" marL="338328">
               <a:buNone/>
             </a:pPr>
             <a:r>
@@ -6110,7 +6110,7 @@
           </a:bodyPr>
           <a:lstStyle/>
           <a:p>
-            <a:pPr lvl="0" indent="-338328" marL="338328">
+            <a:pPr lvl="0" indent="-182880" marL="338328">
               <a:buNone/>
             </a:pPr>
             <a:r>
@@ -6137,7 +6137,7 @@
           </a:bodyPr>
           <a:lstStyle/>
           <a:p>
-            <a:pPr lvl="0" indent="-338328" marL="338328">
+            <a:pPr lvl="0" indent="-182880" marL="338328">
               <a:buNone/>
             </a:pPr>
             <a:r>
@@ -6154,7 +6154,7 @@
             </a:r>
           </a:p>
           <a:p>
-            <a:pPr lvl="0" indent="-338328" marL="338328">
+            <a:pPr lvl="0" indent="-182880" marL="338328">
               <a:buNone/>
             </a:pPr>
             <a:r>
@@ -6163,7 +6163,7 @@
             </a:r>
           </a:p>
           <a:p>
-            <a:pPr lvl="0" indent="-338328" marL="338328">
+            <a:pPr lvl="0" indent="-182880" marL="338328">
               <a:buNone/>
             </a:pPr>
             <a:r>
@@ -6180,7 +6180,7 @@
             </a:r>
           </a:p>
           <a:p>
-            <a:pPr lvl="0" indent="-338328" marL="338328">
+            <a:pPr lvl="0" indent="-182880" marL="338328">
               <a:buNone/>
             </a:pPr>
             <a:r>
@@ -6263,7 +6263,7 @@
           </a:bodyPr>
           <a:lstStyle/>
           <a:p>
-            <a:pPr lvl="0" indent="-338328" marL="338328">
+            <a:pPr lvl="0" indent="-182880" marL="338328">
               <a:buNone/>
             </a:pPr>
             <a:r>
@@ -6290,7 +6290,7 @@
           </a:bodyPr>
           <a:lstStyle/>
           <a:p>
-            <a:pPr lvl="0" indent="-338328" marL="338328">
+            <a:pPr lvl="0" indent="-182880" marL="338328">
               <a:spcBef>
                 <a:spcPts val="3000"/>
               </a:spcBef>
@@ -6302,21 +6302,21 @@
             </a:r>
           </a:p>
           <a:p>
-            <a:pPr lvl="0" marL="338328" indent="-338328"/>
+            <a:pPr lvl="0" marL="338328" indent="-182880"/>
             <a:r>
               <a:rPr/>
               <a:t>The fitting for TAT affinity is improved for better fitting and better visualization.</a:t>
             </a:r>
           </a:p>
           <a:p>
-            <a:pPr lvl="0" marL="338328" indent="-338328"/>
+            <a:pPr lvl="0" marL="338328" indent="-182880"/>
             <a:r>
               <a:rPr/>
               <a:t>Time dependent images for SPT analysis is done for 0, 1, 2, 3, 4 and 5 hours after TAT addition.</a:t>
             </a:r>
           </a:p>
           <a:p>
-            <a:pPr lvl="0" indent="-338328" marL="338328">
+            <a:pPr lvl="0" indent="-182880" marL="338328">
               <a:spcBef>
                 <a:spcPts val="3000"/>
               </a:spcBef>
@@ -6328,14 +6328,14 @@
             </a:r>
           </a:p>
           <a:p>
-            <a:pPr lvl="0" marL="338328" indent="-338328"/>
+            <a:pPr lvl="0" marL="338328" indent="-182880"/>
             <a:r>
               <a:rPr/>
               <a:t>…</a:t>
             </a:r>
           </a:p>
           <a:p>
-            <a:pPr lvl="0" indent="-338328" marL="338328">
+            <a:pPr lvl="0" indent="-182880" marL="338328">
               <a:spcBef>
                 <a:spcPts val="3000"/>
               </a:spcBef>
@@ -6347,14 +6347,14 @@
             </a:r>
           </a:p>
           <a:p>
-            <a:pPr lvl="0" marL="338328" indent="-338328"/>
+            <a:pPr lvl="0" marL="338328" indent="-182880"/>
             <a:r>
               <a:rPr/>
               <a:t>Based on the concentration dependence of LNPs the next round of experiments will be done with 10x higher concentration.</a:t>
             </a:r>
           </a:p>
           <a:p>
-            <a:pPr lvl="0" indent="-338328" marL="338328">
+            <a:pPr lvl="0" indent="-182880" marL="338328">
               <a:spcBef>
                 <a:spcPts val="3000"/>
               </a:spcBef>
@@ -6366,14 +6366,14 @@
             </a:r>
           </a:p>
           <a:p>
-            <a:pPr lvl="0" marL="338328" indent="-338328"/>
+            <a:pPr lvl="0" marL="338328" indent="-182880"/>
             <a:r>
               <a:rPr/>
               <a:t>Temperature dependent experiment shows that domains formed after TAT addition disappear at 50 °C. However, when the sample is cooled down to room temperature, the domains do not reappear.</a:t>
             </a:r>
           </a:p>
           <a:p>
-            <a:pPr lvl="0" marL="338328" indent="-338328"/>
+            <a:pPr lvl="0" marL="338328" indent="-182880"/>
             <a:r>
               <a:rPr/>
               <a:t>Next is to analyze the SPT for DOPE-Atto488 and Cholesterol-Bodipy to see if the diffusion coefficient is different for the two markers.</a:t>

</xml_diff>